<commit_message>
fix: completely remove all LaTeX syntax and replace with clean Unicode math across all 12 decks
</commit_message>
<xml_diff>
--- a/生成的课件/00_管理经济学_绪论_管理经济学的对象与方法.pptx
+++ b/生成的课件/00_管理经济学_绪论_管理经济学的对象与方法.pptx
@@ -4028,7 +4028,7 @@
                 <a:latin typeface="Times New Roman"/>
                 <a:ea typeface="宋体"/>
               </a:rPr>
-              <a:t>  1. 沉没成本与向前看原则</a:t>
+              <a:t>1. 沉没成本与向前看原则</a:t>
             </a:r>
           </a:p>
         </p:txBody>
@@ -4071,7 +4071,7 @@
                 <a:latin typeface="Times New Roman"/>
                 <a:ea typeface="宋体"/>
               </a:rPr>
-              <a:t>（1）沉没成本定义： </a:t>
+              <a:t>（1）沉没成本定义：</a:t>
             </a:r>
             <a:r>
               <a:rPr sz="1250" b="0">
@@ -4101,7 +4101,7 @@
                 <a:latin typeface="Times New Roman"/>
                 <a:ea typeface="宋体"/>
               </a:rPr>
-              <a:t>（2）向前看核心法则： </a:t>
+              <a:t>（2）向前看核心法则：</a:t>
             </a:r>
             <a:r>
               <a:rPr sz="1250" b="0">
@@ -4131,7 +4131,7 @@
                 <a:latin typeface="Times New Roman"/>
                 <a:ea typeface="宋体"/>
               </a:rPr>
-              <a:t>（3）心理学沉没成本谬误： </a:t>
+              <a:t>（3）心理学沉没成本谬误：</a:t>
             </a:r>
             <a:r>
               <a:rPr sz="1250" b="0">
@@ -4161,7 +4161,7 @@
                 <a:latin typeface="Times New Roman"/>
                 <a:ea typeface="宋体"/>
               </a:rPr>
-              <a:t>（4）理性决策准则： </a:t>
+              <a:t>（4）理性决策准则：</a:t>
             </a:r>
             <a:r>
               <a:rPr sz="1250" b="0">
@@ -4271,7 +4271,7 @@
                 <a:latin typeface="Times New Roman"/>
                 <a:ea typeface="宋体"/>
               </a:rPr>
-              <a:t>  2. 例0-1：航空公司空座机票降价决策</a:t>
+              <a:t>2. 例0-1：航空公司空座机票降价决策</a:t>
             </a:r>
           </a:p>
         </p:txBody>
@@ -4314,7 +4314,7 @@
                 <a:latin typeface="Times New Roman"/>
                 <a:ea typeface="宋体"/>
               </a:rPr>
-              <a:t>（1）已知条件： </a:t>
+              <a:t>（1）已知条件：</a:t>
             </a:r>
             <a:r>
               <a:rPr sz="1250" b="0">
@@ -4344,7 +4344,7 @@
                 <a:latin typeface="Times New Roman"/>
                 <a:ea typeface="宋体"/>
               </a:rPr>
-              <a:t>（2）决策情境： </a:t>
+              <a:t>（2）决策情境：</a:t>
             </a:r>
             <a:r>
               <a:rPr sz="1250" b="0">
@@ -4374,7 +4374,7 @@
                 <a:latin typeface="Times New Roman"/>
                 <a:ea typeface="宋体"/>
               </a:rPr>
-              <a:t>（3）传统思维误区： </a:t>
+              <a:t>（3）传统思维误区：</a:t>
             </a:r>
             <a:r>
               <a:rPr sz="1250" b="0">
@@ -4404,7 +4404,7 @@
                 <a:latin typeface="Times New Roman"/>
                 <a:ea typeface="宋体"/>
               </a:rPr>
-              <a:t>（4）边际分析求解： </a:t>
+              <a:t>（4）边际分析求解：</a:t>
             </a:r>
             <a:r>
               <a:rPr sz="1250" b="0">
@@ -4471,7 +4471,7 @@
                 <a:latin typeface="Times New Roman"/>
                 <a:ea typeface="宋体"/>
               </a:rPr>
-              <a:t>  ★ 核心要点：沉没成本是历史覆水，边际分析让企业彻底摆脱历史包袱，专注未来增量利润创造。</a:t>
+              <a:t>★ 核心要点：沉没成本是历史覆水，边际分析让企业彻底摆脱历史包袱，专注未来增量利润创造。</a:t>
             </a:r>
           </a:p>
         </p:txBody>
@@ -4878,7 +4878,7 @@
                 <a:latin typeface="Times New Roman"/>
                 <a:ea typeface="宋体"/>
               </a:rPr>
-              <a:t>  1. 无约束业务量最优化数学定理</a:t>
+              <a:t>1. 无约束业务量最优化数学定理</a:t>
             </a:r>
           </a:p>
         </p:txBody>
@@ -4921,7 +4921,7 @@
                 <a:latin typeface="Times New Roman"/>
                 <a:ea typeface="宋体"/>
               </a:rPr>
-              <a:t>（1）总利润函数： </a:t>
+              <a:t>（1）总利润函数：</a:t>
             </a:r>
             <a:r>
               <a:rPr sz="1250" b="0">
@@ -4931,7 +4931,7 @@
                 <a:latin typeface="Times New Roman"/>
                 <a:ea typeface="宋体"/>
               </a:rPr>
-              <a:t>\pi(Q) = TR(Q) - TC(Q)</a:t>
+              <a:t>π(Q) = TR(Q) - TC(Q)</a:t>
             </a:r>
           </a:p>
           <a:p>
@@ -4951,7 +4951,7 @@
                 <a:latin typeface="Times New Roman"/>
                 <a:ea typeface="宋体"/>
               </a:rPr>
-              <a:t>（2）一阶极值条件（FOC）： </a:t>
+              <a:t>（2）一阶极值条件（FOC）：</a:t>
             </a:r>
             <a:r>
               <a:rPr sz="1250" b="0">
@@ -4961,7 +4961,7 @@
                 <a:latin typeface="Times New Roman"/>
                 <a:ea typeface="宋体"/>
               </a:rPr>
-              <a:t>d\pi / dQ = dTR/dQ - dTC/dQ = 0 \implies MR = MC</a:t>
+              <a:t>dπ / dQ = dTR/dQ - dTC/dQ = 0 ⇒ MR = MC</a:t>
             </a:r>
           </a:p>
           <a:p>
@@ -4981,7 +4981,7 @@
                 <a:latin typeface="Times New Roman"/>
                 <a:ea typeface="宋体"/>
               </a:rPr>
-              <a:t>（3）二阶充分条件（SOC）： </a:t>
+              <a:t>（3）二阶充分条件（SOC）：</a:t>
             </a:r>
             <a:r>
               <a:rPr sz="1250" b="0">
@@ -4991,7 +4991,7 @@
                 <a:latin typeface="Times New Roman"/>
                 <a:ea typeface="宋体"/>
               </a:rPr>
-              <a:t>d^2\pi / dQ^2 = dMR/dQ - dMC/dQ &lt; 0 \implies dMC/dQ &gt; dMR/dQ</a:t>
+              <a:t>d²π / dQ² = dMR/dQ - dMC/dQ &lt; 0 ⇒ dMC/dQ &gt; dMR/dQ</a:t>
             </a:r>
           </a:p>
           <a:p>
@@ -5011,7 +5011,7 @@
                 <a:latin typeface="Times New Roman"/>
                 <a:ea typeface="宋体"/>
               </a:rPr>
-              <a:t>（4）经济学含义： </a:t>
+              <a:t>（4）经济学含义：</a:t>
             </a:r>
             <a:r>
               <a:rPr sz="1250" b="0">
@@ -5121,7 +5121,7 @@
                 <a:latin typeface="Times New Roman"/>
                 <a:ea typeface="宋体"/>
               </a:rPr>
-              <a:t>  2. 例0-2：某企业最优产量与最大利润求解</a:t>
+              <a:t>2. 例0-2：某企业最优产量与最大利润求解</a:t>
             </a:r>
           </a:p>
         </p:txBody>
@@ -5164,7 +5164,7 @@
                 <a:latin typeface="Times New Roman"/>
                 <a:ea typeface="宋体"/>
               </a:rPr>
-              <a:t>（1）函数方程： </a:t>
+              <a:t>（1）函数方程：</a:t>
             </a:r>
             <a:r>
               <a:rPr sz="1250" b="0">
@@ -5174,7 +5174,7 @@
                 <a:latin typeface="Times New Roman"/>
                 <a:ea typeface="宋体"/>
               </a:rPr>
-              <a:t>总收入 TR = 100Q - 0.5Q^2，总成本 TC = 10Q + 0.5Q^2 + 100</a:t>
+              <a:t>总收入 TR = 100Q - 0.5Q²，总成本 TC = 10Q + 0.5Q² + 100</a:t>
             </a:r>
           </a:p>
           <a:p>
@@ -5194,7 +5194,7 @@
                 <a:latin typeface="Times New Roman"/>
                 <a:ea typeface="宋体"/>
               </a:rPr>
-              <a:t>（2）求导推导： </a:t>
+              <a:t>（2）求导推导：</a:t>
             </a:r>
             <a:r>
               <a:rPr sz="1250" b="0">
@@ -5224,7 +5224,7 @@
                 <a:latin typeface="Times New Roman"/>
                 <a:ea typeface="宋体"/>
               </a:rPr>
-              <a:t>（3）极值联立： </a:t>
+              <a:t>（3）极值联立：</a:t>
             </a:r>
             <a:r>
               <a:rPr sz="1250" b="0">
@@ -5234,7 +5234,7 @@
                 <a:latin typeface="Times New Roman"/>
                 <a:ea typeface="宋体"/>
               </a:rPr>
-              <a:t>令 MR = MC \implies 100 - Q = 10 + Q \implies 2Q = 90 \implies Q^* = 45 单位</a:t>
+              <a:t>令 MR = MC ⇒ 100 - Q = 10 + Q ⇒ 2Q = 90 ⇒ Q* = 45 单位</a:t>
             </a:r>
           </a:p>
           <a:p>
@@ -5254,7 +5254,7 @@
                 <a:latin typeface="Times New Roman"/>
                 <a:ea typeface="宋体"/>
               </a:rPr>
-              <a:t>（4）最大利润： </a:t>
+              <a:t>（4）最大利润：</a:t>
             </a:r>
             <a:r>
               <a:rPr sz="1250" b="0">
@@ -5264,7 +5264,7 @@
                 <a:latin typeface="Times New Roman"/>
                 <a:ea typeface="宋体"/>
               </a:rPr>
-              <a:t>\pi_{max} = TR(45) - TC(45) = (100\times 45 - 0.5\times 45^2) - (10\times 45 + 0.5\times 45^2 + 100) = 1925 元</a:t>
+              <a:t>π_max = TR(45) - TC(45) = (100 × 45 - 0.5 × 45²) - (10 × 45 + 0.5 × 45² + 100) = 1925 元</a:t>
             </a:r>
           </a:p>
         </p:txBody>
@@ -5321,7 +5321,7 @@
                 <a:latin typeface="Times New Roman"/>
                 <a:ea typeface="宋体"/>
               </a:rPr>
-              <a:t>  ★ 核心要点：在无约束资源条件下，微观经济决策的黄金法则是将业务量推进至 MR = MC 的均衡点。</a:t>
+              <a:t>★ 核心要点：在无约束资源条件下，微观经济决策的黄金法则是将业务量推进至 MR = MC 的均衡点。</a:t>
             </a:r>
           </a:p>
         </p:txBody>
@@ -5728,7 +5728,7 @@
                 <a:latin typeface="Times New Roman"/>
                 <a:ea typeface="宋体"/>
               </a:rPr>
-              <a:t>  1. 有约束资源分配的等边际法则</a:t>
+              <a:t>1. 有约束资源分配的等边际法则</a:t>
             </a:r>
           </a:p>
         </p:txBody>
@@ -5771,7 +5771,7 @@
                 <a:latin typeface="Times New Roman"/>
                 <a:ea typeface="宋体"/>
               </a:rPr>
-              <a:t>（1）约束问题设定： </a:t>
+              <a:t>（1）约束问题设定：</a:t>
             </a:r>
             <a:r>
               <a:rPr sz="1250" b="0">
@@ -5781,7 +5781,7 @@
                 <a:latin typeface="Times New Roman"/>
                 <a:ea typeface="宋体"/>
               </a:rPr>
-              <a:t>企业拥有有限的资源总量 \bar{X}（如固定预算、总产能），需在多个部门/产品间分配。</a:t>
+              <a:t>企业拥有有限的资源总量 X̄（如固定预算、总产能），需在多个部门/产品间分配。</a:t>
             </a:r>
           </a:p>
           <a:p>
@@ -5801,7 +5801,7 @@
                 <a:latin typeface="Times New Roman"/>
                 <a:ea typeface="宋体"/>
               </a:rPr>
-              <a:t>（2）数学规划模型： </a:t>
+              <a:t>（2）数学规划模型：</a:t>
             </a:r>
             <a:r>
               <a:rPr sz="1250" b="0">
@@ -5811,7 +5811,7 @@
                 <a:latin typeface="Times New Roman"/>
                 <a:ea typeface="宋体"/>
               </a:rPr>
-              <a:t>Max \sum \pi_i(X_i) \quad s.t. \quad \sum X_i = \bar{X}</a:t>
+              <a:t>Max ∑ πᵢ(Xᵢ) s.t. ∑ Xᵢ = X̄</a:t>
             </a:r>
           </a:p>
           <a:p>
@@ -5831,7 +5831,7 @@
                 <a:latin typeface="Times New Roman"/>
                 <a:ea typeface="宋体"/>
               </a:rPr>
-              <a:t>（3）拉格朗日乘数推导： </a:t>
+              <a:t>（3）拉格朗日乘数推导：</a:t>
             </a:r>
             <a:r>
               <a:rPr sz="1250" b="0">
@@ -5841,7 +5841,7 @@
                 <a:latin typeface="Times New Roman"/>
                 <a:ea typeface="宋体"/>
               </a:rPr>
-              <a:t>最优分配必须满足：各用途的边际收益相等，即 MU_1/P_1 = MU_2/P_2 = ... = \lambda</a:t>
+              <a:t>最优分配必须满足：各用途的边际收益相等，即 MU₁/P₁ = MU₂/P₂ = ... = λ</a:t>
             </a:r>
           </a:p>
           <a:p>
@@ -5861,7 +5861,7 @@
                 <a:latin typeface="Times New Roman"/>
                 <a:ea typeface="宋体"/>
               </a:rPr>
-              <a:t>（4）管理启示： </a:t>
+              <a:t>（4）管理启示：</a:t>
             </a:r>
             <a:r>
               <a:rPr sz="1250" b="0">
@@ -5971,7 +5971,7 @@
                 <a:latin typeface="Times New Roman"/>
                 <a:ea typeface="宋体"/>
               </a:rPr>
-              <a:t>  2. 例0-3 &amp; 例0-4：广告预算与多工厂产能分配</a:t>
+              <a:t>2. 例0-3 &amp; 例0-4：广告预算与多工厂产能分配</a:t>
             </a:r>
           </a:p>
         </p:txBody>
@@ -6014,7 +6014,7 @@
                 <a:latin typeface="Times New Roman"/>
                 <a:ea typeface="宋体"/>
               </a:rPr>
-              <a:t>（1）例0-3 广告预算分配： </a:t>
+              <a:t>（1）例0-3 广告预算分配：</a:t>
             </a:r>
             <a:r>
               <a:rPr sz="1250" b="0">
@@ -6044,7 +6044,7 @@
                 <a:latin typeface="Times New Roman"/>
                 <a:ea typeface="宋体"/>
               </a:rPr>
-              <a:t>（2）例0-4 双工厂产量分配： </a:t>
+              <a:t>（2）例0-4 双工厂产量分配：</a:t>
             </a:r>
             <a:r>
               <a:rPr sz="1250" b="0">
@@ -6074,7 +6074,7 @@
                 <a:latin typeface="Times New Roman"/>
                 <a:ea typeface="宋体"/>
               </a:rPr>
-              <a:t>（3）推论检验： </a:t>
+              <a:t>（3）推论检验：</a:t>
             </a:r>
             <a:r>
               <a:rPr sz="1250" b="0">
@@ -6141,7 +6141,7 @@
                 <a:latin typeface="Times New Roman"/>
                 <a:ea typeface="宋体"/>
               </a:rPr>
-              <a:t>  ★ 核心要点：有限资源分配的核心原则：把每一块钱投在能产生最大边际产出的地方，实现全系统等边际收益。</a:t>
+              <a:t>★ 核心要点：有限资源分配的核心原则：把每一块钱投在能产生最大边际产出的地方，实现全系统等边际收益。</a:t>
             </a:r>
           </a:p>
         </p:txBody>
@@ -6548,7 +6548,7 @@
                 <a:latin typeface="Times New Roman"/>
                 <a:ea typeface="宋体"/>
               </a:rPr>
-              <a:t>  1. 增量分析法的原理与适用场景</a:t>
+              <a:t>1. 增量分析法的原理与适用场景</a:t>
             </a:r>
           </a:p>
         </p:txBody>
@@ -6591,7 +6591,7 @@
                 <a:latin typeface="Times New Roman"/>
                 <a:ea typeface="宋体"/>
               </a:rPr>
-              <a:t>（1）基本定义： </a:t>
+              <a:t>（1）基本定义：</a:t>
             </a:r>
             <a:r>
               <a:rPr sz="1250" b="0">
@@ -6601,7 +6601,7 @@
                 <a:latin typeface="Times New Roman"/>
                 <a:ea typeface="宋体"/>
               </a:rPr>
-              <a:t>增量分析法是分析某项管理决策引起的总收入变化（增量收入 \Delta TR）与总成本变化（增量成本 \Delta TC）的差额法。</a:t>
+              <a:t>增量分析法是分析某项管理决策引起的总收入变化（增量收入 Δ TR）与总成本变化（增量成本 Δ TC）的差额法。</a:t>
             </a:r>
           </a:p>
           <a:p>
@@ -6621,7 +6621,7 @@
                 <a:latin typeface="Times New Roman"/>
                 <a:ea typeface="宋体"/>
               </a:rPr>
-              <a:t>（2）决策黄金准则： </a:t>
+              <a:t>（2）决策黄金准则：</a:t>
             </a:r>
             <a:r>
               <a:rPr sz="1250" b="0">
@@ -6631,7 +6631,7 @@
                 <a:latin typeface="Times New Roman"/>
                 <a:ea typeface="宋体"/>
               </a:rPr>
-              <a:t>增量利润 \Delta \pi = \Delta TR - \Delta TC &gt; 0，则方案可行且盈利；反之不可行。</a:t>
+              <a:t>增量利润 Δ π = Δ TR - Δ TC &gt; 0，则方案可行且盈利；反之不可行。</a:t>
             </a:r>
           </a:p>
           <a:p>
@@ -6651,7 +6651,7 @@
                 <a:latin typeface="Times New Roman"/>
                 <a:ea typeface="宋体"/>
               </a:rPr>
-              <a:t>（3）与边际分析关系： </a:t>
+              <a:t>（3）与边际分析关系：</a:t>
             </a:r>
             <a:r>
               <a:rPr sz="1250" b="0">
@@ -6681,7 +6681,7 @@
                 <a:latin typeface="Times New Roman"/>
                 <a:ea typeface="宋体"/>
               </a:rPr>
-              <a:t>（4）核心优势： </a:t>
+              <a:t>（4）核心优势：</a:t>
             </a:r>
             <a:r>
               <a:rPr sz="1250" b="0">
@@ -6791,7 +6791,7 @@
                 <a:latin typeface="Times New Roman"/>
                 <a:ea typeface="宋体"/>
               </a:rPr>
-              <a:t>  2. 生活中的经济学 0-1：随到随走的机票策略</a:t>
+              <a:t>2. 生活中的经济学 0-1：随到随走的机票策略</a:t>
             </a:r>
           </a:p>
         </p:txBody>
@@ -6834,7 +6834,7 @@
                 <a:latin typeface="Times New Roman"/>
                 <a:ea typeface="宋体"/>
               </a:rPr>
-              <a:t>（1）商业现象： </a:t>
+              <a:t>（1）商业现象：</a:t>
             </a:r>
             <a:r>
               <a:rPr sz="1250" b="0">
@@ -6864,7 +6864,7 @@
                 <a:latin typeface="Times New Roman"/>
                 <a:ea typeface="宋体"/>
               </a:rPr>
-              <a:t>（2）传统会计眼光： </a:t>
+              <a:t>（2）传统会计眼光：</a:t>
             </a:r>
             <a:r>
               <a:rPr sz="1250" b="0">
@@ -6894,7 +6894,7 @@
                 <a:latin typeface="Times New Roman"/>
                 <a:ea typeface="宋体"/>
               </a:rPr>
-              <a:t>（3）增量经济学真谛： </a:t>
+              <a:t>（3）增量经济学真谛：</a:t>
             </a:r>
             <a:r>
               <a:rPr sz="1250" b="0">
@@ -6924,7 +6924,7 @@
                 <a:latin typeface="Times New Roman"/>
                 <a:ea typeface="宋体"/>
               </a:rPr>
-              <a:t>（4）企业战略启示： </a:t>
+              <a:t>（4）企业战略启示：</a:t>
             </a:r>
             <a:r>
               <a:rPr sz="1250" b="0">
@@ -6991,7 +6991,7 @@
                 <a:latin typeface="Times New Roman"/>
                 <a:ea typeface="宋体"/>
               </a:rPr>
-              <a:t>  ★ 核心要点：增量分析法是现代管理会计与商业实战中最锋利的定量决策手术刀。</a:t>
+              <a:t>★ 核心要点：增量分析法是现代管理会计与商业实战中最锋利的定量决策手术刀。</a:t>
             </a:r>
           </a:p>
         </p:txBody>
@@ -7705,7 +7705,7 @@
                 <a:latin typeface="Times New Roman"/>
                 <a:ea typeface="宋体"/>
               </a:rPr>
-              <a:t>  1. 企业的性质与存在根源</a:t>
+              <a:t>1. 企业的性质与存在根源</a:t>
             </a:r>
           </a:p>
         </p:txBody>
@@ -7748,7 +7748,7 @@
                 <a:latin typeface="Times New Roman"/>
                 <a:ea typeface="宋体"/>
               </a:rPr>
-              <a:t>（1）罗纳德·科斯经典理论： </a:t>
+              <a:t>（1）罗纳德·科斯经典理论：</a:t>
             </a:r>
             <a:r>
               <a:rPr sz="1250" b="0">
@@ -7778,7 +7778,7 @@
                 <a:latin typeface="Times New Roman"/>
                 <a:ea typeface="宋体"/>
               </a:rPr>
-              <a:t>（2）企业边界确定： </a:t>
+              <a:t>（2）企业边界确定：</a:t>
             </a:r>
             <a:r>
               <a:rPr sz="1250" b="0">
@@ -7808,7 +7808,7 @@
                 <a:latin typeface="Times New Roman"/>
                 <a:ea typeface="宋体"/>
               </a:rPr>
-              <a:t>（3）现代企业法人属性： </a:t>
+              <a:t>（3）现代企业法人属性：</a:t>
             </a:r>
             <a:r>
               <a:rPr sz="1250" b="0">
@@ -7918,7 +7918,7 @@
                 <a:latin typeface="Times New Roman"/>
                 <a:ea typeface="宋体"/>
               </a:rPr>
-              <a:t>  2. 企业在国民经济中的地位与功能</a:t>
+              <a:t>2. 企业在国民经济中的地位与功能</a:t>
             </a:r>
           </a:p>
         </p:txBody>
@@ -7961,7 +7961,7 @@
                 <a:latin typeface="Times New Roman"/>
                 <a:ea typeface="宋体"/>
               </a:rPr>
-              <a:t>（1）生产财富的基本细胞： </a:t>
+              <a:t>（1）生产财富的基本细胞：</a:t>
             </a:r>
             <a:r>
               <a:rPr sz="1250" b="0">
@@ -7991,7 +7991,7 @@
                 <a:latin typeface="Times New Roman"/>
                 <a:ea typeface="宋体"/>
               </a:rPr>
-              <a:t>（2）技术创新的核心引擎： </a:t>
+              <a:t>（2）技术创新的核心引擎：</a:t>
             </a:r>
             <a:r>
               <a:rPr sz="1250" b="0">
@@ -8021,7 +8021,7 @@
                 <a:latin typeface="Times New Roman"/>
                 <a:ea typeface="宋体"/>
               </a:rPr>
-              <a:t>（3）就业与税收的支柱载体： </a:t>
+              <a:t>（3）就业与税收的支柱载体：</a:t>
             </a:r>
             <a:r>
               <a:rPr sz="1250" b="0">
@@ -8088,7 +8088,7 @@
                 <a:latin typeface="Times New Roman"/>
                 <a:ea typeface="宋体"/>
               </a:rPr>
-              <a:t>  ★ 核心要点：企业通过内部化协同降低社会总交易费用，是市场经济体制下财富创造与技术革新的核心主体。</a:t>
+              <a:t>★ 核心要点：企业通过内部化协同降低社会总交易费用，是市场经济体制下财富创造与技术革新的核心主体。</a:t>
             </a:r>
           </a:p>
         </p:txBody>
@@ -8495,7 +8495,7 @@
                 <a:latin typeface="Times New Roman"/>
                 <a:ea typeface="宋体"/>
               </a:rPr>
-              <a:t>  1. 企业的短期目标：利益相关者满意</a:t>
+              <a:t>1. 企业的短期目标：利益相关者满意</a:t>
             </a:r>
           </a:p>
         </p:txBody>
@@ -8538,7 +8538,7 @@
                 <a:latin typeface="Times New Roman"/>
                 <a:ea typeface="宋体"/>
               </a:rPr>
-              <a:t>（1）股东群体： </a:t>
+              <a:t>（1）股东群体：</a:t>
             </a:r>
             <a:r>
               <a:rPr sz="1150" b="0">
@@ -8568,7 +8568,7 @@
                 <a:latin typeface="Times New Roman"/>
                 <a:ea typeface="宋体"/>
               </a:rPr>
-              <a:t>（2）广大员工： </a:t>
+              <a:t>（2）广大员工：</a:t>
             </a:r>
             <a:r>
               <a:rPr sz="1150" b="0">
@@ -8598,7 +8598,7 @@
                 <a:latin typeface="Times New Roman"/>
                 <a:ea typeface="宋体"/>
               </a:rPr>
-              <a:t>（3）客户与消费者： </a:t>
+              <a:t>（3）客户与消费者：</a:t>
             </a:r>
             <a:r>
               <a:rPr sz="1150" b="0">
@@ -8628,7 +8628,7 @@
                 <a:latin typeface="Times New Roman"/>
                 <a:ea typeface="宋体"/>
               </a:rPr>
-              <a:t>（4）债权人与供应商： </a:t>
+              <a:t>（4）债权人与供应商：</a:t>
             </a:r>
             <a:r>
               <a:rPr sz="1150" b="0">
@@ -8658,7 +8658,7 @@
                 <a:latin typeface="Times New Roman"/>
                 <a:ea typeface="宋体"/>
               </a:rPr>
-              <a:t>（5）政府与公众： </a:t>
+              <a:t>（5）政府与公众：</a:t>
             </a:r>
             <a:r>
               <a:rPr sz="1150" b="0">
@@ -8768,7 +8768,7 @@
                 <a:latin typeface="Times New Roman"/>
                 <a:ea typeface="宋体"/>
               </a:rPr>
-              <a:t>  2. 企业的长期目标：企业总价值最大化</a:t>
+              <a:t>2. 企业的长期目标：企业总价值最大化</a:t>
             </a:r>
           </a:p>
         </p:txBody>
@@ -8811,7 +8811,7 @@
                 <a:latin typeface="Times New Roman"/>
                 <a:ea typeface="宋体"/>
               </a:rPr>
-              <a:t>（1）企业价值定义模型： </a:t>
+              <a:t>（1）企业价值定义模型：</a:t>
             </a:r>
             <a:r>
               <a:rPr sz="1150" b="0">
@@ -8821,7 +8821,7 @@
                 <a:latin typeface="Times New Roman"/>
                 <a:ea typeface="宋体"/>
               </a:rPr>
-              <a:t>V = \sum_{t=1}^n \frac{\pi_t}{(1 + r)^t}，其中 \pi_t 为第 t 期预期利润，r 为贴现率。</a:t>
+              <a:t>V = ∑ⁿ (πₜ) / ((1 + r)ᵗ)，其中 πₜ 为第 t 期预期利润，r 为贴现率。</a:t>
             </a:r>
           </a:p>
           <a:p>
@@ -8841,7 +8841,7 @@
                 <a:latin typeface="Times New Roman"/>
                 <a:ea typeface="宋体"/>
               </a:rPr>
-              <a:t>（2）优于单纯利润最大化： </a:t>
+              <a:t>（2）优于单纯利润最大化：</a:t>
             </a:r>
             <a:r>
               <a:rPr sz="1150" b="0">
@@ -8871,7 +8871,7 @@
                 <a:latin typeface="Times New Roman"/>
                 <a:ea typeface="宋体"/>
               </a:rPr>
-              <a:t>   • 克服时间忽视： </a:t>
+              <a:t>• 克服时间忽视：</a:t>
             </a:r>
             <a:r>
               <a:rPr sz="1150" b="0">
@@ -8901,7 +8901,7 @@
                 <a:latin typeface="Times New Roman"/>
                 <a:ea typeface="宋体"/>
               </a:rPr>
-              <a:t>   • 克服风险忽视： </a:t>
+              <a:t>• 克服风险忽视：</a:t>
             </a:r>
             <a:r>
               <a:rPr sz="1150" b="0">
@@ -8931,7 +8931,7 @@
                 <a:latin typeface="Times New Roman"/>
                 <a:ea typeface="宋体"/>
               </a:rPr>
-              <a:t>   • 克服质量忽视： </a:t>
+              <a:t>• 克服质量忽视：</a:t>
             </a:r>
             <a:r>
               <a:rPr sz="1150" b="0">
@@ -8998,7 +8998,7 @@
                 <a:latin typeface="Times New Roman"/>
                 <a:ea typeface="宋体"/>
               </a:rPr>
-              <a:t>  ★ 核心要点：现代公司治理的核心理念：短期内平衡各方利益相关者诉求，长期内坚定追求企业未来现金流折现值最大化。</a:t>
+              <a:t>★ 核心要点：现代公司治理的核心理念：短期内平衡各方利益相关者诉求，长期内坚定追求企业未来现金流折现值最大化。</a:t>
             </a:r>
           </a:p>
         </p:txBody>
@@ -9405,7 +9405,7 @@
                 <a:latin typeface="Times New Roman"/>
                 <a:ea typeface="宋体"/>
               </a:rPr>
-              <a:t>  1. 案例0-2：海尔集团三大发展战略演进</a:t>
+              <a:t>1. 案例0-2：海尔集团三大发展战略演进</a:t>
             </a:r>
           </a:p>
         </p:txBody>
@@ -9448,7 +9448,7 @@
                 <a:latin typeface="Times New Roman"/>
                 <a:ea typeface="宋体"/>
               </a:rPr>
-              <a:t>（1）名牌战略阶段（1984-1991）： </a:t>
+              <a:t>（1）名牌战略阶段（1984-1991）：</a:t>
             </a:r>
             <a:r>
               <a:rPr sz="1250" b="0">
@@ -9478,7 +9478,7 @@
                 <a:latin typeface="Times New Roman"/>
                 <a:ea typeface="宋体"/>
               </a:rPr>
-              <a:t>（2）多元化战略阶段（1992-1998）： </a:t>
+              <a:t>（2）多元化战略阶段（1992-1998）：</a:t>
             </a:r>
             <a:r>
               <a:rPr sz="1250" b="0">
@@ -9508,7 +9508,7 @@
                 <a:latin typeface="Times New Roman"/>
                 <a:ea typeface="宋体"/>
               </a:rPr>
-              <a:t>（3）国际化战略阶段（1998以后）： </a:t>
+              <a:t>（3）国际化战略阶段（1998以后）：</a:t>
             </a:r>
             <a:r>
               <a:rPr sz="1250" b="0">
@@ -9618,7 +9618,7 @@
                 <a:latin typeface="Times New Roman"/>
                 <a:ea typeface="宋体"/>
               </a:rPr>
-              <a:t>  2. 委托代理问题与激励约束机制</a:t>
+              <a:t>2. 委托代理问题与激励约束机制</a:t>
             </a:r>
           </a:p>
         </p:txBody>
@@ -9661,7 +9661,7 @@
                 <a:latin typeface="Times New Roman"/>
                 <a:ea typeface="宋体"/>
               </a:rPr>
-              <a:t>（1）代理问题根源： </a:t>
+              <a:t>（1）代理问题根源：</a:t>
             </a:r>
             <a:r>
               <a:rPr sz="1250" b="0">
@@ -9691,7 +9691,7 @@
                 <a:latin typeface="Times New Roman"/>
                 <a:ea typeface="宋体"/>
               </a:rPr>
-              <a:t>（2）激励机制设计： </a:t>
+              <a:t>（2）激励机制设计：</a:t>
             </a:r>
             <a:r>
               <a:rPr sz="1250" b="0">
@@ -9721,7 +9721,7 @@
                 <a:latin typeface="Times New Roman"/>
                 <a:ea typeface="宋体"/>
               </a:rPr>
-              <a:t>（3）外部市场约束： </a:t>
+              <a:t>（3）外部市场约束：</a:t>
             </a:r>
             <a:r>
               <a:rPr sz="1250" b="0">
@@ -9788,7 +9788,7 @@
                 <a:latin typeface="Times New Roman"/>
                 <a:ea typeface="宋体"/>
               </a:rPr>
-              <a:t>  ★ 核心要点：战略演进体现长期价值创造路径，完善的公司治理则是防范内部人控制、保障战略落地的制度基石。</a:t>
+              <a:t>★ 核心要点：战略演进体现长期价值创造路径，完善的公司治理则是防范内部人控制、保障战略落地的制度基石。</a:t>
             </a:r>
           </a:p>
         </p:txBody>
@@ -10502,7 +10502,7 @@
                 <a:latin typeface="Times New Roman"/>
                 <a:ea typeface="宋体"/>
               </a:rPr>
-              <a:t>  1. 成本与利润的核心公式界定</a:t>
+              <a:t>1. 成本与利润的核心公式界定</a:t>
             </a:r>
           </a:p>
         </p:txBody>
@@ -10545,7 +10545,7 @@
                 <a:latin typeface="Times New Roman"/>
                 <a:ea typeface="宋体"/>
               </a:rPr>
-              <a:t>（1）会计利润： </a:t>
+              <a:t>（1）会计利润：</a:t>
             </a:r>
             <a:r>
               <a:rPr sz="1150" b="0">
@@ -10555,7 +10555,7 @@
                 <a:latin typeface="Times New Roman"/>
                 <a:ea typeface="宋体"/>
               </a:rPr>
-              <a:t>\text{会计利润} = \text{总收益 (TR)} - \text{外显成本 (Explicit Costs)}</a:t>
+              <a:t>会计利润 = 总收益 (TR) - 外显成本 (Explicit Costs)</a:t>
             </a:r>
           </a:p>
           <a:p>
@@ -10575,7 +10575,7 @@
                 <a:latin typeface="Times New Roman"/>
                 <a:ea typeface="宋体"/>
               </a:rPr>
-              <a:t>（2）外显成本： </a:t>
+              <a:t>（2）外显成本：</a:t>
             </a:r>
             <a:r>
               <a:rPr sz="1150" b="0">
@@ -10605,7 +10605,7 @@
                 <a:latin typeface="Times New Roman"/>
                 <a:ea typeface="宋体"/>
               </a:rPr>
-              <a:t>（3）经济成本： </a:t>
+              <a:t>（3）经济成本：</a:t>
             </a:r>
             <a:r>
               <a:rPr sz="1150" b="0">
@@ -10615,7 +10615,7 @@
                 <a:latin typeface="Times New Roman"/>
                 <a:ea typeface="宋体"/>
               </a:rPr>
-              <a:t>\text{经济成本} = \text{外显成本} + \text{内涵成本 (Implicit Costs)} = \text{全部机会成本}</a:t>
+              <a:t>经济成本 = 外显成本 + 内涵成本 (Implicit Costs) = 全部机会成本</a:t>
             </a:r>
           </a:p>
           <a:p>
@@ -10635,7 +10635,7 @@
                 <a:latin typeface="Times New Roman"/>
                 <a:ea typeface="宋体"/>
               </a:rPr>
-              <a:t>（4）内涵成本： </a:t>
+              <a:t>（4）内涵成本：</a:t>
             </a:r>
             <a:r>
               <a:rPr sz="1150" b="0">
@@ -10665,7 +10665,7 @@
                 <a:latin typeface="Times New Roman"/>
                 <a:ea typeface="宋体"/>
               </a:rPr>
-              <a:t>（5）经济利润： </a:t>
+              <a:t>（5）经济利润：</a:t>
             </a:r>
             <a:r>
               <a:rPr sz="1150" b="0">
@@ -10675,7 +10675,7 @@
                 <a:latin typeface="Times New Roman"/>
                 <a:ea typeface="宋体"/>
               </a:rPr>
-              <a:t>\text{经济利润} = \text{总收益} - \text{经济成本} = \text{会计利润} - \text{内涵成本}</a:t>
+              <a:t>经济利润 = 总收益 - 经济成本 = 会计利润 - 内涵成本</a:t>
             </a:r>
           </a:p>
         </p:txBody>
@@ -10775,7 +10775,7 @@
                 <a:latin typeface="Times New Roman"/>
                 <a:ea typeface="宋体"/>
               </a:rPr>
-              <a:t>  2. 经济利润在资源配置中的指示灯功能</a:t>
+              <a:t>2. 经济利润在资源配置中的指示灯功能</a:t>
             </a:r>
           </a:p>
         </p:txBody>
@@ -10818,7 +10818,7 @@
                 <a:latin typeface="Times New Roman"/>
                 <a:ea typeface="宋体"/>
               </a:rPr>
-              <a:t>（1）经济利润 &gt; 0： </a:t>
+              <a:t>（1）经济利润 &gt; 0：</a:t>
             </a:r>
             <a:r>
               <a:rPr sz="1250" b="0">
@@ -10848,7 +10848,7 @@
                 <a:latin typeface="Times New Roman"/>
                 <a:ea typeface="宋体"/>
               </a:rPr>
-              <a:t>（2）经济利润 = 0： </a:t>
+              <a:t>（2）经济利润 = 0：</a:t>
             </a:r>
             <a:r>
               <a:rPr sz="1250" b="0">
@@ -10878,7 +10878,7 @@
                 <a:latin typeface="Times New Roman"/>
                 <a:ea typeface="宋体"/>
               </a:rPr>
-              <a:t>（3）经济利润 &lt; 0： </a:t>
+              <a:t>（3）经济利润 &lt; 0：</a:t>
             </a:r>
             <a:r>
               <a:rPr sz="1250" b="0">
@@ -10945,7 +10945,7 @@
                 <a:latin typeface="Times New Roman"/>
                 <a:ea typeface="宋体"/>
               </a:rPr>
-              <a:t>  ★ 核心要点：决策必须以经济利润而非会计利润为准绳，经济利润才是指引社会稀缺资源流向最高效领域的指南针。</a:t>
+              <a:t>★ 核心要点：决策必须以经济利润而非会计利润为准绳，经济利润才是指引社会稀缺资源流向最高效领域的指南针。</a:t>
             </a:r>
           </a:p>
         </p:txBody>
@@ -12947,7 +12947,7 @@
                 <a:latin typeface="Times New Roman"/>
                 <a:ea typeface="宋体"/>
               </a:rPr>
-              <a:t>  1. 自有资金与自有资产</a:t>
+              <a:t>1. 自有资金与自有资产</a:t>
             </a:r>
           </a:p>
         </p:txBody>
@@ -12990,7 +12990,7 @@
                 <a:latin typeface="Times New Roman"/>
                 <a:ea typeface="宋体"/>
               </a:rPr>
-              <a:t>（1）业主自有资金： </a:t>
+              <a:t>（1）业主自有资金：</a:t>
             </a:r>
             <a:r>
               <a:rPr sz="1200" b="0">
@@ -13020,7 +13020,7 @@
                 <a:latin typeface="Times New Roman"/>
                 <a:ea typeface="宋体"/>
               </a:rPr>
-              <a:t>（2）业主自有房产土地： </a:t>
+              <a:t>（2）业主自有房产土地：</a:t>
             </a:r>
             <a:r>
               <a:rPr sz="1200" b="0">
@@ -13050,7 +13050,7 @@
                 <a:latin typeface="Times New Roman"/>
                 <a:ea typeface="宋体"/>
               </a:rPr>
-              <a:t>（3）业主自身劳动力： </a:t>
+              <a:t>（3）业主自身劳动力：</a:t>
             </a:r>
             <a:r>
               <a:rPr sz="1200" b="0">
@@ -13160,7 +13160,7 @@
                 <a:latin typeface="Times New Roman"/>
                 <a:ea typeface="宋体"/>
               </a:rPr>
-              <a:t>  2. 设备与机器使用状态</a:t>
+              <a:t>2. 设备与机器使用状态</a:t>
             </a:r>
           </a:p>
         </p:txBody>
@@ -13203,7 +13203,7 @@
                 <a:latin typeface="Times New Roman"/>
                 <a:ea typeface="宋体"/>
               </a:rPr>
-              <a:t>（1）闲置设备的使用： </a:t>
+              <a:t>（1）闲置设备的使用：</a:t>
             </a:r>
             <a:r>
               <a:rPr sz="1200" b="0">
@@ -13233,7 +13233,7 @@
                 <a:latin typeface="Times New Roman"/>
                 <a:ea typeface="宋体"/>
               </a:rPr>
-              <a:t>（2）转产设备的使用： </a:t>
+              <a:t>（2）转产设备的使用：</a:t>
             </a:r>
             <a:r>
               <a:rPr sz="1200" b="0">
@@ -13263,7 +13263,7 @@
                 <a:latin typeface="Times New Roman"/>
                 <a:ea typeface="宋体"/>
               </a:rPr>
-              <a:t>（3）设备折旧的机会成本： </a:t>
+              <a:t>（3）设备折旧的机会成本：</a:t>
             </a:r>
             <a:r>
               <a:rPr sz="1200" b="0">
@@ -13373,7 +13373,7 @@
                 <a:latin typeface="Times New Roman"/>
                 <a:ea typeface="宋体"/>
               </a:rPr>
-              <a:t>  3. 库存原材料与零部件</a:t>
+              <a:t>3. 库存原材料与零部件</a:t>
             </a:r>
           </a:p>
         </p:txBody>
@@ -13416,7 +13416,7 @@
                 <a:latin typeface="Times New Roman"/>
                 <a:ea typeface="宋体"/>
               </a:rPr>
-              <a:t>（1）有现成市价的库存： </a:t>
+              <a:t>（1）有现成市价的库存：</a:t>
             </a:r>
             <a:r>
               <a:rPr sz="1200" b="0">
@@ -13446,7 +13446,7 @@
                 <a:latin typeface="Times New Roman"/>
                 <a:ea typeface="宋体"/>
               </a:rPr>
-              <a:t>（2）专有定制无市价库存： </a:t>
+              <a:t>（2）专有定制无市价库存：</a:t>
             </a:r>
             <a:r>
               <a:rPr sz="1200" b="0">
@@ -13513,7 +13513,7 @@
                 <a:latin typeface="Times New Roman"/>
                 <a:ea typeface="宋体"/>
               </a:rPr>
-              <a:t>  ★ 核心要点：机会成本的本质不是实际付出的现金，而是决策中被放弃的所有备选方案中价值最高的那一个。</a:t>
+              <a:t>★ 核心要点：机会成本的本质不是实际付出的现金，而是决策中被放弃的所有备选方案中价值最高的那一个。</a:t>
             </a:r>
           </a:p>
         </p:txBody>
@@ -13920,7 +13920,7 @@
                 <a:latin typeface="Times New Roman"/>
                 <a:ea typeface="宋体"/>
               </a:rPr>
-              <a:t>  例0-5 至 例0-8 逐题推演与决策判定</a:t>
+              <a:t>例0-5 至 例0-8 逐题推演与决策判定</a:t>
             </a:r>
           </a:p>
         </p:txBody>
@@ -13963,7 +13963,7 @@
                 <a:latin typeface="Times New Roman"/>
                 <a:ea typeface="宋体"/>
               </a:rPr>
-              <a:t>【例0-5 资金机会成本】 </a:t>
+              <a:t>【例0-5 资金机会成本】</a:t>
             </a:r>
             <a:r>
               <a:rPr sz="1200" b="0">
@@ -14013,7 +14013,7 @@
                 <a:latin typeface="Times New Roman"/>
                 <a:ea typeface="宋体"/>
               </a:rPr>
-              <a:t>【例0-6 闲置厂房利用】 </a:t>
+              <a:t>【例0-6 闲置厂房利用】</a:t>
             </a:r>
             <a:r>
               <a:rPr sz="1200" b="0">
@@ -14073,7 +14073,7 @@
                 <a:latin typeface="Times New Roman"/>
                 <a:ea typeface="宋体"/>
               </a:rPr>
-              <a:t>【例0-7 转产产品决策】 </a:t>
+              <a:t>【例0-7 转产产品决策】</a:t>
             </a:r>
             <a:r>
               <a:rPr sz="1200" b="0">
@@ -14103,7 +14103,7 @@
                 <a:latin typeface="Times New Roman"/>
                 <a:ea typeface="宋体"/>
               </a:rPr>
-              <a:t>【例0-8 库存钢材成本计量】 </a:t>
+              <a:t>【例0-8 库存钢材成本计量】</a:t>
             </a:r>
             <a:r>
               <a:rPr sz="1200" b="0">
@@ -14180,7 +14180,7 @@
                 <a:latin typeface="Times New Roman"/>
                 <a:ea typeface="宋体"/>
               </a:rPr>
-              <a:t>  ★ 核心精要：掌握机会成本的动态计量方法，是避免企业落入'账面盈利、经济亏损'陷阱的根本法宝。</a:t>
+              <a:t>★ 核心精要：掌握机会成本的动态计量方法，是避免企业落入'账面盈利、经济亏损'陷阱的根本法宝。</a:t>
             </a:r>
           </a:p>
         </p:txBody>
@@ -14587,7 +14587,7 @@
                 <a:latin typeface="Times New Roman"/>
                 <a:ea typeface="宋体"/>
               </a:rPr>
-              <a:t>  1. 例0-9 详细收支数据推演</a:t>
+              <a:t>1. 例0-9 详细收支数据推演</a:t>
             </a:r>
           </a:p>
         </p:txBody>
@@ -14630,7 +14630,7 @@
                 <a:latin typeface="Times New Roman"/>
                 <a:ea typeface="宋体"/>
               </a:rPr>
-              <a:t>（1）背景情况： </a:t>
+              <a:t>（1）背景情况：</a:t>
             </a:r>
             <a:r>
               <a:rPr sz="1150" b="0">
@@ -14660,7 +14660,7 @@
                 <a:latin typeface="Times New Roman"/>
                 <a:ea typeface="宋体"/>
               </a:rPr>
-              <a:t>（2）年度实际收支： </a:t>
+              <a:t>（2）年度实际收支：</a:t>
             </a:r>
             <a:r>
               <a:rPr sz="1150" b="0">
@@ -14690,7 +14690,7 @@
                 <a:latin typeface="Times New Roman"/>
                 <a:ea typeface="宋体"/>
               </a:rPr>
-              <a:t>（3）会计利润核算： </a:t>
+              <a:t>（3）会计利润核算：</a:t>
             </a:r>
             <a:r>
               <a:rPr sz="1150" b="0">
@@ -14700,7 +14700,7 @@
                 <a:latin typeface="Times New Roman"/>
                 <a:ea typeface="宋体"/>
               </a:rPr>
-              <a:t>\text{会计利润} = 30 - 15 = 15 \text{ 万元（账面看似盈利丰厚！）}。</a:t>
+              <a:t>会计利润 = 30 - 15 = 15 万元（账面看似盈利丰厚！）。</a:t>
             </a:r>
           </a:p>
           <a:p>
@@ -14720,7 +14720,7 @@
                 <a:latin typeface="Times New Roman"/>
                 <a:ea typeface="宋体"/>
               </a:rPr>
-              <a:t>（4）内涵成本识别： </a:t>
+              <a:t>（4）内涵成本识别：</a:t>
             </a:r>
             <a:r>
               <a:rPr sz="1150" b="0">
@@ -14750,7 +14750,7 @@
                 <a:latin typeface="Times New Roman"/>
                 <a:ea typeface="宋体"/>
               </a:rPr>
-              <a:t>（5）经济利润核算： </a:t>
+              <a:t>（5）经济利润核算：</a:t>
             </a:r>
             <a:r>
               <a:rPr sz="1150" b="0">
@@ -14760,7 +14760,7 @@
                 <a:latin typeface="Times New Roman"/>
                 <a:ea typeface="宋体"/>
               </a:rPr>
-              <a:t>\text{经济利润} = 15 - 10 = +5 \text{ 万元 &gt; 0}，说明辞职创业实现了资源优化配置，决策正确！</a:t>
+              <a:t>经济利润 = 15 - 10 = +5 万元 &gt; 0，说明辞职创业实现了资源优化配置，决策正确！</a:t>
             </a:r>
           </a:p>
         </p:txBody>
@@ -14860,7 +14860,7 @@
                 <a:latin typeface="Times New Roman"/>
                 <a:ea typeface="宋体"/>
               </a:rPr>
-              <a:t>  2. 正常利润与外显/内涵成本全景矩阵</a:t>
+              <a:t>2. 正常利润与外显/内涵成本全景矩阵</a:t>
             </a:r>
           </a:p>
         </p:txBody>
@@ -14903,7 +14903,7 @@
                 <a:latin typeface="Times New Roman"/>
                 <a:ea typeface="宋体"/>
               </a:rPr>
-              <a:t>（1）正常利润本质： </a:t>
+              <a:t>（1）正常利润本质：</a:t>
             </a:r>
             <a:r>
               <a:rPr sz="1250" b="0">
@@ -14933,7 +14933,7 @@
                 <a:latin typeface="Times New Roman"/>
                 <a:ea typeface="宋体"/>
               </a:rPr>
-              <a:t>（2）外显成本（Explicit）： </a:t>
+              <a:t>（2）外显成本（Explicit）：</a:t>
             </a:r>
             <a:r>
               <a:rPr sz="1250" b="0">
@@ -14963,7 +14963,7 @@
                 <a:latin typeface="Times New Roman"/>
                 <a:ea typeface="宋体"/>
               </a:rPr>
-              <a:t>（3）内涵成本（Implicit）： </a:t>
+              <a:t>（3）内涵成本（Implicit）：</a:t>
             </a:r>
             <a:r>
               <a:rPr sz="1250" b="0">
@@ -14993,7 +14993,7 @@
                 <a:latin typeface="Times New Roman"/>
                 <a:ea typeface="宋体"/>
               </a:rPr>
-              <a:t>（4）生活中的经济学0-2启示： </a:t>
+              <a:t>（4）生活中的经济学0-2启示：</a:t>
             </a:r>
             <a:r>
               <a:rPr sz="1250" b="0">
@@ -15060,7 +15060,7 @@
                 <a:latin typeface="Times New Roman"/>
                 <a:ea typeface="宋体"/>
               </a:rPr>
-              <a:t>  ★ 核心要点：经济利润是扣减包括正常利润在内的全部机会成本后的超额剩余，是创业与资本配置的唯一硬标准。</a:t>
+              <a:t>★ 核心要点：经济利润是扣减包括正常利润在内的全部机会成本后的超额剩余，是创业与资本配置的唯一硬标准。</a:t>
             </a:r>
           </a:p>
         </p:txBody>
@@ -15467,7 +15467,7 @@
                 <a:latin typeface="Times New Roman"/>
                 <a:ea typeface="宋体"/>
               </a:rPr>
-              <a:t>  学科使命与理论框架</a:t>
+              <a:t>学科使命与理论框架</a:t>
             </a:r>
           </a:p>
         </p:txBody>
@@ -15671,7 +15671,7 @@
                 <a:latin typeface="Times New Roman"/>
                 <a:ea typeface="宋体"/>
               </a:rPr>
-              <a:t>  边际分析与向前看</a:t>
+              <a:t>边际分析与向前看</a:t>
             </a:r>
           </a:p>
         </p:txBody>
@@ -15875,7 +15875,7 @@
                 <a:latin typeface="Times New Roman"/>
                 <a:ea typeface="宋体"/>
               </a:rPr>
-              <a:t>  契约理论与价值最大化</a:t>
+              <a:t>契约理论与价值最大化</a:t>
             </a:r>
           </a:p>
         </p:txBody>
@@ -16079,7 +16079,7 @@
                 <a:latin typeface="Times New Roman"/>
                 <a:ea typeface="宋体"/>
               </a:rPr>
-              <a:t>  经济利润与机会成本</a:t>
+              <a:t>经济利润与机会成本</a:t>
             </a:r>
           </a:p>
         </p:txBody>
@@ -16240,7 +16240,7 @@
                 <a:latin typeface="Times New Roman"/>
                 <a:ea typeface="宋体"/>
               </a:rPr>
-              <a:t>  ★ 战略结语：牢固树立'向前看'的边际思维与'不计沉没、精算机会'的成本观，是现代卓越管理者的第一核心素养。</a:t>
+              <a:t>★ 战略结语：牢固树立'向前看'的边际思维与'不计沉没、精算机会'的成本观，是现代卓越管理者的第一核心素养。</a:t>
             </a:r>
           </a:p>
         </p:txBody>
@@ -16647,7 +16647,7 @@
                 <a:latin typeface="Times New Roman"/>
                 <a:ea typeface="宋体"/>
               </a:rPr>
-              <a:t>  课后复习思考题与 MBA 讨论案例（严格对应课本习题）</a:t>
+              <a:t>课后复习思考题与 MBA 讨论案例（严格对应课本习题）</a:t>
             </a:r>
           </a:p>
         </p:txBody>
@@ -16690,7 +16690,7 @@
                 <a:latin typeface="Times New Roman"/>
                 <a:ea typeface="宋体"/>
               </a:rPr>
-              <a:t>1. </a:t>
+              <a:t>1.</a:t>
             </a:r>
             <a:r>
               <a:rPr sz="1150" b="0">
@@ -16720,7 +16720,7 @@
                 <a:latin typeface="Times New Roman"/>
                 <a:ea typeface="宋体"/>
               </a:rPr>
-              <a:t>2. </a:t>
+              <a:t>2.</a:t>
             </a:r>
             <a:r>
               <a:rPr sz="1150" b="0">
@@ -16750,7 +16750,7 @@
                 <a:latin typeface="Times New Roman"/>
                 <a:ea typeface="宋体"/>
               </a:rPr>
-              <a:t>3. </a:t>
+              <a:t>3.</a:t>
             </a:r>
             <a:r>
               <a:rPr sz="1150" b="0">
@@ -16780,7 +16780,7 @@
                 <a:latin typeface="Times New Roman"/>
                 <a:ea typeface="宋体"/>
               </a:rPr>
-              <a:t>4. </a:t>
+              <a:t>4.</a:t>
             </a:r>
             <a:r>
               <a:rPr sz="1150" b="0">
@@ -16810,7 +16810,7 @@
                 <a:latin typeface="Times New Roman"/>
                 <a:ea typeface="宋体"/>
               </a:rPr>
-              <a:t>5. </a:t>
+              <a:t>5.</a:t>
             </a:r>
             <a:r>
               <a:rPr sz="1150" b="0">
@@ -16840,7 +16840,7 @@
                 <a:latin typeface="Times New Roman"/>
                 <a:ea typeface="宋体"/>
               </a:rPr>
-              <a:t>6. </a:t>
+              <a:t>6.</a:t>
             </a:r>
             <a:r>
               <a:rPr sz="1150" b="0">
@@ -16850,7 +16850,7 @@
                 <a:latin typeface="Times New Roman"/>
                 <a:ea typeface="宋体"/>
               </a:rPr>
-              <a:t>【作业题1】某垄断企业产品成本函数为 TC = Q^2 + 200Q + 400，需求函数为 P = 1000 - Q。试求利润最大化的最优产量、价格及最大利润。</a:t>
+              <a:t>【作业题1】某垄断企业产品成本函数为 TC = Q² + 200Q + 400，需求函数为 P = 1000 - Q。试求利润最大化的最优产量、价格及最大利润。</a:t>
             </a:r>
           </a:p>
           <a:p>
@@ -16870,7 +16870,7 @@
                 <a:latin typeface="Times New Roman"/>
                 <a:ea typeface="宋体"/>
               </a:rPr>
-              <a:t>7. </a:t>
+              <a:t>7.</a:t>
             </a:r>
             <a:r>
               <a:rPr sz="1150" b="0">
@@ -17594,7 +17594,7 @@
                 <a:latin typeface="Times New Roman"/>
                 <a:ea typeface="宋体"/>
               </a:rPr>
-              <a:t>  1. 研究对象与学科交叉属性</a:t>
+              <a:t>1. 研究对象与学科交叉属性</a:t>
             </a:r>
           </a:p>
         </p:txBody>
@@ -17637,7 +17637,7 @@
                 <a:latin typeface="Times New Roman"/>
                 <a:ea typeface="宋体"/>
               </a:rPr>
-              <a:t>（1）学科定义： </a:t>
+              <a:t>（1）学科定义：</a:t>
             </a:r>
             <a:r>
               <a:rPr sz="1250" b="0">
@@ -17667,7 +17667,7 @@
                 <a:latin typeface="Times New Roman"/>
                 <a:ea typeface="宋体"/>
               </a:rPr>
-              <a:t>（2）理论桥梁： </a:t>
+              <a:t>（2）理论桥梁：</a:t>
             </a:r>
             <a:r>
               <a:rPr sz="1250" b="0">
@@ -17697,7 +17697,7 @@
                 <a:latin typeface="Times New Roman"/>
                 <a:ea typeface="宋体"/>
               </a:rPr>
-              <a:t>（3）决策工具： </a:t>
+              <a:t>（3）决策工具：</a:t>
             </a:r>
             <a:r>
               <a:rPr sz="1250" b="0">
@@ -17727,7 +17727,7 @@
                 <a:latin typeface="Times New Roman"/>
                 <a:ea typeface="宋体"/>
               </a:rPr>
-              <a:t>（4）核心任务： </a:t>
+              <a:t>（4）核心任务：</a:t>
             </a:r>
             <a:r>
               <a:rPr sz="1250" b="0">
@@ -17837,7 +17837,7 @@
                 <a:latin typeface="Times New Roman"/>
                 <a:ea typeface="宋体"/>
               </a:rPr>
-              <a:t>  2. 资源配置决策的核心问题</a:t>
+              <a:t>2. 资源配置决策的核心问题</a:t>
             </a:r>
           </a:p>
         </p:txBody>
@@ -17880,7 +17880,7 @@
                 <a:latin typeface="Times New Roman"/>
                 <a:ea typeface="宋体"/>
               </a:rPr>
-              <a:t>（1）生产什么： </a:t>
+              <a:t>（1）生产什么：</a:t>
             </a:r>
             <a:r>
               <a:rPr sz="1250" b="0">
@@ -17910,7 +17910,7 @@
                 <a:latin typeface="Times New Roman"/>
                 <a:ea typeface="宋体"/>
               </a:rPr>
-              <a:t>（2）生产多少： </a:t>
+              <a:t>（2）生产多少：</a:t>
             </a:r>
             <a:r>
               <a:rPr sz="1250" b="0">
@@ -17940,7 +17940,7 @@
                 <a:latin typeface="Times New Roman"/>
                 <a:ea typeface="宋体"/>
               </a:rPr>
-              <a:t>（3）如何生产： </a:t>
+              <a:t>（3）如何生产：</a:t>
             </a:r>
             <a:r>
               <a:rPr sz="1250" b="0">
@@ -17970,7 +17970,7 @@
                 <a:latin typeface="Times New Roman"/>
                 <a:ea typeface="宋体"/>
               </a:rPr>
-              <a:t>（4）为谁生产： </a:t>
+              <a:t>（4）为谁生产：</a:t>
             </a:r>
             <a:r>
               <a:rPr sz="1250" b="0">
@@ -18037,7 +18037,7 @@
                 <a:latin typeface="Times New Roman"/>
                 <a:ea typeface="宋体"/>
               </a:rPr>
-              <a:t>  ★ 核心要点：管理经济学以微观经济学为理论基石，以决策科学为方法工具，以企业资源优化配置为终极目标。</a:t>
+              <a:t>★ 核心要点：管理经济学以微观经济学为理论基石，以决策科学为方法工具，以企业资源优化配置为终极目标。</a:t>
             </a:r>
           </a:p>
         </p:txBody>
@@ -18613,7 +18613,7 @@
                 <a:latin typeface="Times New Roman"/>
                 <a:ea typeface="宋体"/>
               </a:rPr>
-              <a:t>（1）研究目的： </a:t>
+              <a:t>（1）研究目的：</a:t>
             </a:r>
             <a:r>
               <a:rPr sz="1200" b="0">
@@ -18643,7 +18643,7 @@
                 <a:latin typeface="Times New Roman"/>
                 <a:ea typeface="宋体"/>
               </a:rPr>
-              <a:t>（2）核心假设： </a:t>
+              <a:t>（2）核心假设：</a:t>
             </a:r>
             <a:r>
               <a:rPr sz="1200" b="0">
@@ -18673,7 +18673,7 @@
                 <a:latin typeface="Times New Roman"/>
                 <a:ea typeface="宋体"/>
               </a:rPr>
-              <a:t>（3）关系： </a:t>
+              <a:t>（3）关系：</a:t>
             </a:r>
             <a:r>
               <a:rPr sz="1200" b="0">
@@ -18952,7 +18952,7 @@
                 <a:latin typeface="Times New Roman"/>
                 <a:ea typeface="宋体"/>
               </a:rPr>
-              <a:t>（1）工具支撑： </a:t>
+              <a:t>（1）工具支撑：</a:t>
             </a:r>
             <a:r>
               <a:rPr sz="1200" b="0">
@@ -18982,7 +18982,7 @@
                 <a:latin typeface="Times New Roman"/>
                 <a:ea typeface="宋体"/>
               </a:rPr>
-              <a:t>（2）量化分析： </a:t>
+              <a:t>（2）量化分析：</a:t>
             </a:r>
             <a:r>
               <a:rPr sz="1200" b="0">
@@ -19012,7 +19012,7 @@
                 <a:latin typeface="Times New Roman"/>
                 <a:ea typeface="宋体"/>
               </a:rPr>
-              <a:t>（3）关系： </a:t>
+              <a:t>（3）关系：</a:t>
             </a:r>
             <a:r>
               <a:rPr sz="1200" b="0">
@@ -19291,7 +19291,7 @@
                 <a:latin typeface="Times New Roman"/>
                 <a:ea typeface="宋体"/>
               </a:rPr>
-              <a:t>（1）数据来源： </a:t>
+              <a:t>（1）数据来源：</a:t>
             </a:r>
             <a:r>
               <a:rPr sz="1200" b="0">
@@ -19321,7 +19321,7 @@
                 <a:latin typeface="Times New Roman"/>
                 <a:ea typeface="宋体"/>
               </a:rPr>
-              <a:t>（2）本质差异： </a:t>
+              <a:t>（2）本质差异：</a:t>
             </a:r>
             <a:r>
               <a:rPr sz="1200" b="0">
@@ -19351,7 +19351,7 @@
                 <a:latin typeface="Times New Roman"/>
                 <a:ea typeface="宋体"/>
               </a:rPr>
-              <a:t>（3）关系： </a:t>
+              <a:t>（3）关系：</a:t>
             </a:r>
             <a:r>
               <a:rPr sz="1200" b="0">
@@ -19630,7 +19630,7 @@
                 <a:latin typeface="Times New Roman"/>
                 <a:ea typeface="宋体"/>
               </a:rPr>
-              <a:t>（1）应用场景： </a:t>
+              <a:t>（1）应用场景：</a:t>
             </a:r>
             <a:r>
               <a:rPr sz="1200" b="0">
@@ -19660,7 +19660,7 @@
                 <a:latin typeface="Times New Roman"/>
                 <a:ea typeface="宋体"/>
               </a:rPr>
-              <a:t>（2）决策落地： </a:t>
+              <a:t>（2）决策落地：</a:t>
             </a:r>
             <a:r>
               <a:rPr sz="1200" b="0">
@@ -19690,7 +19690,7 @@
                 <a:latin typeface="Times New Roman"/>
                 <a:ea typeface="宋体"/>
               </a:rPr>
-              <a:t>（3）关系： </a:t>
+              <a:t>（3）关系：</a:t>
             </a:r>
             <a:r>
               <a:rPr sz="1200" b="0">
@@ -19757,7 +19757,7 @@
                 <a:latin typeface="Times New Roman"/>
                 <a:ea typeface="宋体"/>
               </a:rPr>
-              <a:t>  ★ 重点启示：管理经济学是微观理论与企业职能管理的交叉枢纽，重在运用前瞻性经济思维赋能实战决策。</a:t>
+              <a:t>★ 重点启示：管理经济学是微观理论与企业职能管理的交叉枢纽，重在运用前瞻性经济思维赋能实战决策。</a:t>
             </a:r>
           </a:p>
         </p:txBody>
@@ -20471,7 +20471,7 @@
                 <a:latin typeface="Times New Roman"/>
                 <a:ea typeface="宋体"/>
               </a:rPr>
-              <a:t>  1. 决策前端分析流程（步骤 1 ~ 4）</a:t>
+              <a:t>1. 决策前端分析流程（步骤 1 ~ 4）</a:t>
             </a:r>
           </a:p>
         </p:txBody>
@@ -20514,7 +20514,7 @@
                 <a:latin typeface="Times New Roman"/>
                 <a:ea typeface="宋体"/>
               </a:rPr>
-              <a:t>（1）确定目标： </a:t>
+              <a:t>（1）确定目标：</a:t>
             </a:r>
             <a:r>
               <a:rPr sz="1250" b="0">
@@ -20544,7 +20544,7 @@
                 <a:latin typeface="Times New Roman"/>
                 <a:ea typeface="宋体"/>
               </a:rPr>
-              <a:t>（2）界定问题： </a:t>
+              <a:t>（2）界定问题：</a:t>
             </a:r>
             <a:r>
               <a:rPr sz="1250" b="0">
@@ -20574,7 +20574,7 @@
                 <a:latin typeface="Times New Roman"/>
                 <a:ea typeface="宋体"/>
               </a:rPr>
-              <a:t>（3）找出原因： </a:t>
+              <a:t>（3）找出原因：</a:t>
             </a:r>
             <a:r>
               <a:rPr sz="1250" b="0">
@@ -20604,7 +20604,7 @@
                 <a:latin typeface="Times New Roman"/>
                 <a:ea typeface="宋体"/>
               </a:rPr>
-              <a:t>（4）提出方案： </a:t>
+              <a:t>（4）提出方案：</a:t>
             </a:r>
             <a:r>
               <a:rPr sz="1250" b="0">
@@ -20714,7 +20714,7 @@
                 <a:latin typeface="Times New Roman"/>
                 <a:ea typeface="宋体"/>
               </a:rPr>
-              <a:t>  2. 决策后端执行流程（步骤 5 ~ 7）</a:t>
+              <a:t>2. 决策后端执行流程（步骤 5 ~ 7）</a:t>
             </a:r>
           </a:p>
         </p:txBody>
@@ -20757,7 +20757,7 @@
                 <a:latin typeface="Times New Roman"/>
                 <a:ea typeface="宋体"/>
               </a:rPr>
-              <a:t>（1）收集数据： </a:t>
+              <a:t>（1）收集数据：</a:t>
             </a:r>
             <a:r>
               <a:rPr sz="1250" b="0">
@@ -20787,7 +20787,7 @@
                 <a:latin typeface="Times New Roman"/>
                 <a:ea typeface="宋体"/>
               </a:rPr>
-              <a:t>（2）评估方案： </a:t>
+              <a:t>（2）评估方案：</a:t>
             </a:r>
             <a:r>
               <a:rPr sz="1250" b="0">
@@ -20817,7 +20817,7 @@
                 <a:latin typeface="Times New Roman"/>
                 <a:ea typeface="宋体"/>
               </a:rPr>
-              <a:t>（3）实施监控： </a:t>
+              <a:t>（3）实施监控：</a:t>
             </a:r>
             <a:r>
               <a:rPr sz="1250" b="0">
@@ -20884,7 +20884,7 @@
                 <a:latin typeface="Times New Roman"/>
                 <a:ea typeface="宋体"/>
               </a:rPr>
-              <a:t>  ★ 核心要点：科学决策是一个闭环迭代系统，严格按七步流程推进可最大程度规避拍脑袋决策的灾难性风险。</a:t>
+              <a:t>★ 核心要点：科学决策是一个闭环迭代系统，严格按七步流程推进可最大程度规避拍脑袋决策的灾难性风险。</a:t>
             </a:r>
           </a:p>
         </p:txBody>
@@ -21291,7 +21291,7 @@
                 <a:latin typeface="Times New Roman"/>
                 <a:ea typeface="宋体"/>
               </a:rPr>
-              <a:t>  阶段一：乐观立项</a:t>
+              <a:t>阶段一：乐观立项</a:t>
             </a:r>
           </a:p>
         </p:txBody>
@@ -21515,7 +21515,7 @@
                 <a:latin typeface="Times New Roman"/>
                 <a:ea typeface="宋体"/>
               </a:rPr>
-              <a:t>  阶段二：环境突变</a:t>
+              <a:t>阶段二：环境突变</a:t>
             </a:r>
           </a:p>
         </p:txBody>
@@ -21739,7 +21739,7 @@
                 <a:latin typeface="Times New Roman"/>
                 <a:ea typeface="宋体"/>
               </a:rPr>
-              <a:t>  阶段三：惨败停产</a:t>
+              <a:t>阶段三：惨败停产</a:t>
             </a:r>
           </a:p>
         </p:txBody>
@@ -21963,7 +21963,7 @@
                 <a:latin typeface="Times New Roman"/>
                 <a:ea typeface="宋体"/>
               </a:rPr>
-              <a:t>  管理启示与决策复盘</a:t>
+              <a:t>管理启示与决策复盘</a:t>
             </a:r>
           </a:p>
         </p:txBody>

</xml_diff>